<commit_message>
Included day 5 and 6
</commit_message>
<xml_diff>
--- a/slides/day 3/D3C2_Transformers.pptx
+++ b/slides/day 3/D3C2_Transformers.pptx
@@ -1197,7 +1197,7 @@
           <a:p>
             <a:fld id="{FF5685EE-3D40-0A4E-BB88-46887330FC0A}" type="datetimeFigureOut">
               <a:rPr lang="en-US" smtClean="0"/>
-              <a:t>2/26/26</a:t>
+              <a:t>2/28/26</a:t>
             </a:fld>
             <a:endParaRPr lang="en-US"/>
           </a:p>
@@ -10882,8 +10882,8 @@
           </a:p>
         </p:txBody>
       </p:sp>
-      <mc:AlternateContent xmlns:mc="http://schemas.openxmlformats.org/markup-compatibility/2006">
-        <mc:Choice xmlns:a14="http://schemas.microsoft.com/office/drawing/2010/main" Requires="a14">
+      <mc:AlternateContent xmlns:mc="http://schemas.openxmlformats.org/markup-compatibility/2006" xmlns:a14="http://schemas.microsoft.com/office/drawing/2010/main">
+        <mc:Choice Requires="a14">
           <p:sp>
             <p:nvSpPr>
               <p:cNvPr id="3" name="Content Placeholder 2">
@@ -10974,7 +10974,7 @@
             </p:txBody>
           </p:sp>
         </mc:Choice>
-        <mc:Fallback>
+        <mc:Fallback xmlns="">
           <p:sp>
             <p:nvSpPr>
               <p:cNvPr id="3" name="Content Placeholder 2">
@@ -11711,7 +11711,7 @@
           <a:p>
             <a:r>
               <a:rPr lang="en-US" dirty="0"/>
-              <a:t>Next class</a:t>
+              <a:t>Relevant code</a:t>
             </a:r>
           </a:p>
         </p:txBody>
@@ -11737,10 +11737,6 @@
           <a:bodyPr/>
           <a:lstStyle/>
           <a:p>
-            <a:r>
-              <a:rPr lang="en-US" dirty="0"/>
-              <a:t>Run through </a:t>
-            </a:r>
             <a:r>
               <a:rPr lang="en-US" dirty="0">
                 <a:latin typeface="Courier New" panose="02070309020205020404" pitchFamily="49" charset="0"/>

</xml_diff>